<commit_message>
Fix a samll file
</commit_message>
<xml_diff>
--- a/examples/demo_PPT/backend_test_output.pptx
+++ b/examples/demo_PPT/backend_test_output.pptx
@@ -127,10 +127,11 @@
           <a:lstStyle/>
           <a:p>
             <a:pPr>
-              <a:defRPr sz="1800" b="1">
+              <a:defRPr sz="3000" b="1">
                 <a:solidFill>
-                  <a:srgbClr val="000000"/>
+                  <a:srgbClr val="004F9E"/>
                 </a:solidFill>
+                <a:latin typeface="Segoe UI"/>
               </a:defRPr>
             </a:pPr>
             <a:r>
@@ -161,102 +162,75 @@
               </c:strCache>
             </c:strRef>
           </c:tx>
+          <c:dLbls>
+            <c:numFmt formatCode="#,##0" sourceLinked="0"/>
+            <c:txPr>
+              <a:bodyPr/>
+              <a:lstStyle/>
+              <a:p>
+                <a:pPr>
+                  <a:defRPr sz="1000">
+                    <a:latin typeface="Segoe UI"/>
+                  </a:defRPr>
+                </a:pPr>
+              </a:p>
+            </c:txPr>
+            <c:showLegendKey val="0"/>
+            <c:showVal val="0"/>
+            <c:showCatName val="0"/>
+            <c:showSerName val="0"/>
+            <c:showPercent val="0"/>
+            <c:showBubbleSize val="0"/>
+            <c:showLeaderLines val="1"/>
+          </c:dLbls>
           <c:cat>
             <c:strRef>
-              <c:f>Sheet1!$A$2:$A$15</c:f>
+              <c:f>Sheet1!$A$2:$A$7</c:f>
               <c:strCache>
-                <c:ptCount val="14"/>
+                <c:ptCount val="6"/>
                 <c:pt idx="0">
+                  <c:v>Q4 2024</c:v>
+                </c:pt>
+                <c:pt idx="1">
+                  <c:v>Q3 2024</c:v>
+                </c:pt>
+                <c:pt idx="2">
+                  <c:v>Q2 2024</c:v>
+                </c:pt>
+                <c:pt idx="3">
                   <c:v>Q1 2024</c:v>
-                </c:pt>
-                <c:pt idx="1">
-                  <c:v>Q2 2024</c:v>
-                </c:pt>
-                <c:pt idx="2">
-                  <c:v>Q3 2024</c:v>
-                </c:pt>
-                <c:pt idx="3">
-                  <c:v>Q4 2024</c:v>
                 </c:pt>
                 <c:pt idx="4">
                   <c:v>0</c:v>
                 </c:pt>
                 <c:pt idx="5">
-                  <c:v>0</c:v>
-                </c:pt>
-                <c:pt idx="6">
-                  <c:v>0</c:v>
-                </c:pt>
-                <c:pt idx="7">
-                  <c:v>0</c:v>
-                </c:pt>
-                <c:pt idx="8">
-                  <c:v>0</c:v>
-                </c:pt>
-                <c:pt idx="9">
-                  <c:v>0</c:v>
-                </c:pt>
-                <c:pt idx="10">
-                  <c:v>0</c:v>
-                </c:pt>
-                <c:pt idx="11">
-                  <c:v>0</c:v>
-                </c:pt>
-                <c:pt idx="12">
-                  <c:v>0</c:v>
-                </c:pt>
-                <c:pt idx="13">
-                  <c:v>0</c:v>
+                  <c:v>Other</c:v>
                 </c:pt>
               </c:strCache>
             </c:strRef>
           </c:cat>
           <c:val>
             <c:numRef>
-              <c:f>Sheet1!$B$2:$B$15</c:f>
+              <c:f>Sheet1!$B$2:$B$7</c:f>
               <c:numCache>
                 <c:formatCode>General</c:formatCode>
-                <c:ptCount val="14"/>
+                <c:ptCount val="6"/>
                 <c:pt idx="0">
+                  <c:v>1580000.0</c:v>
+                </c:pt>
+                <c:pt idx="1">
+                  <c:v>1420000.0</c:v>
+                </c:pt>
+                <c:pt idx="2">
+                  <c:v>1350000.0</c:v>
+                </c:pt>
+                <c:pt idx="3">
                   <c:v>1200000.0</c:v>
-                </c:pt>
-                <c:pt idx="1">
-                  <c:v>1350000.0</c:v>
-                </c:pt>
-                <c:pt idx="2">
-                  <c:v>1420000.0</c:v>
-                </c:pt>
-                <c:pt idx="3">
-                  <c:v>1580000.0</c:v>
                 </c:pt>
                 <c:pt idx="4">
                   <c:v>0.0</c:v>
                 </c:pt>
                 <c:pt idx="5">
-                  <c:v>0.0</c:v>
-                </c:pt>
-                <c:pt idx="6">
-                  <c:v>0.0</c:v>
-                </c:pt>
-                <c:pt idx="7">
-                  <c:v>0.0</c:v>
-                </c:pt>
-                <c:pt idx="8">
-                  <c:v>0.0</c:v>
-                </c:pt>
-                <c:pt idx="9">
-                  <c:v>0.0</c:v>
-                </c:pt>
-                <c:pt idx="10">
-                  <c:v>0.0</c:v>
-                </c:pt>
-                <c:pt idx="11">
-                  <c:v>0.0</c:v>
-                </c:pt>
-                <c:pt idx="12">
-                  <c:v>0.0</c:v>
-                </c:pt>
-                <c:pt idx="13">
                   <c:v>0.0</c:v>
                 </c:pt>
               </c:numCache>
@@ -277,102 +251,75 @@
               </c:strCache>
             </c:strRef>
           </c:tx>
+          <c:dLbls>
+            <c:numFmt formatCode="#,##0" sourceLinked="0"/>
+            <c:txPr>
+              <a:bodyPr/>
+              <a:lstStyle/>
+              <a:p>
+                <a:pPr>
+                  <a:defRPr sz="1000">
+                    <a:latin typeface="Segoe UI"/>
+                  </a:defRPr>
+                </a:pPr>
+              </a:p>
+            </c:txPr>
+            <c:showLegendKey val="0"/>
+            <c:showVal val="0"/>
+            <c:showCatName val="0"/>
+            <c:showSerName val="0"/>
+            <c:showPercent val="0"/>
+            <c:showBubbleSize val="0"/>
+            <c:showLeaderLines val="1"/>
+          </c:dLbls>
           <c:cat>
             <c:strRef>
-              <c:f>Sheet1!$A$2:$A$15</c:f>
+              <c:f>Sheet1!$A$2:$A$7</c:f>
               <c:strCache>
-                <c:ptCount val="14"/>
+                <c:ptCount val="6"/>
                 <c:pt idx="0">
+                  <c:v>Q4 2024</c:v>
+                </c:pt>
+                <c:pt idx="1">
+                  <c:v>Q3 2024</c:v>
+                </c:pt>
+                <c:pt idx="2">
+                  <c:v>Q2 2024</c:v>
+                </c:pt>
+                <c:pt idx="3">
                   <c:v>Q1 2024</c:v>
-                </c:pt>
-                <c:pt idx="1">
-                  <c:v>Q2 2024</c:v>
-                </c:pt>
-                <c:pt idx="2">
-                  <c:v>Q3 2024</c:v>
-                </c:pt>
-                <c:pt idx="3">
-                  <c:v>Q4 2024</c:v>
                 </c:pt>
                 <c:pt idx="4">
                   <c:v>0</c:v>
                 </c:pt>
                 <c:pt idx="5">
-                  <c:v>0</c:v>
-                </c:pt>
-                <c:pt idx="6">
-                  <c:v>0</c:v>
-                </c:pt>
-                <c:pt idx="7">
-                  <c:v>0</c:v>
-                </c:pt>
-                <c:pt idx="8">
-                  <c:v>0</c:v>
-                </c:pt>
-                <c:pt idx="9">
-                  <c:v>0</c:v>
-                </c:pt>
-                <c:pt idx="10">
-                  <c:v>0</c:v>
-                </c:pt>
-                <c:pt idx="11">
-                  <c:v>0</c:v>
-                </c:pt>
-                <c:pt idx="12">
-                  <c:v>0</c:v>
-                </c:pt>
-                <c:pt idx="13">
-                  <c:v>0</c:v>
+                  <c:v>Other</c:v>
                 </c:pt>
               </c:strCache>
             </c:strRef>
           </c:cat>
           <c:val>
             <c:numRef>
-              <c:f>Sheet1!$C$2:$C$15</c:f>
+              <c:f>Sheet1!$C$2:$C$7</c:f>
               <c:numCache>
                 <c:formatCode>General</c:formatCode>
-                <c:ptCount val="14"/>
+                <c:ptCount val="6"/>
                 <c:pt idx="0">
+                  <c:v>316000.0</c:v>
+                </c:pt>
+                <c:pt idx="1">
+                  <c:v>284000.0</c:v>
+                </c:pt>
+                <c:pt idx="2">
+                  <c:v>270000.0</c:v>
+                </c:pt>
+                <c:pt idx="3">
                   <c:v>240000.0</c:v>
-                </c:pt>
-                <c:pt idx="1">
-                  <c:v>270000.0</c:v>
-                </c:pt>
-                <c:pt idx="2">
-                  <c:v>284000.0</c:v>
-                </c:pt>
-                <c:pt idx="3">
-                  <c:v>316000.0</c:v>
                 </c:pt>
                 <c:pt idx="4">
                   <c:v>0.0</c:v>
                 </c:pt>
                 <c:pt idx="5">
-                  <c:v>0.0</c:v>
-                </c:pt>
-                <c:pt idx="6">
-                  <c:v>0.0</c:v>
-                </c:pt>
-                <c:pt idx="7">
-                  <c:v>0.0</c:v>
-                </c:pt>
-                <c:pt idx="8">
-                  <c:v>0.0</c:v>
-                </c:pt>
-                <c:pt idx="9">
-                  <c:v>0.0</c:v>
-                </c:pt>
-                <c:pt idx="10">
-                  <c:v>0.0</c:v>
-                </c:pt>
-                <c:pt idx="11">
-                  <c:v>0.0</c:v>
-                </c:pt>
-                <c:pt idx="12">
-                  <c:v>0.0</c:v>
-                </c:pt>
-                <c:pt idx="13">
                   <c:v>0.0</c:v>
                 </c:pt>
               </c:numCache>
@@ -393,102 +340,75 @@
               </c:strCache>
             </c:strRef>
           </c:tx>
+          <c:dLbls>
+            <c:numFmt formatCode="#,##0" sourceLinked="0"/>
+            <c:txPr>
+              <a:bodyPr/>
+              <a:lstStyle/>
+              <a:p>
+                <a:pPr>
+                  <a:defRPr sz="1000">
+                    <a:latin typeface="Segoe UI"/>
+                  </a:defRPr>
+                </a:pPr>
+              </a:p>
+            </c:txPr>
+            <c:showLegendKey val="0"/>
+            <c:showVal val="0"/>
+            <c:showCatName val="0"/>
+            <c:showSerName val="0"/>
+            <c:showPercent val="0"/>
+            <c:showBubbleSize val="0"/>
+            <c:showLeaderLines val="1"/>
+          </c:dLbls>
           <c:cat>
             <c:strRef>
-              <c:f>Sheet1!$A$2:$A$15</c:f>
+              <c:f>Sheet1!$A$2:$A$7</c:f>
               <c:strCache>
-                <c:ptCount val="14"/>
+                <c:ptCount val="6"/>
                 <c:pt idx="0">
+                  <c:v>Q4 2024</c:v>
+                </c:pt>
+                <c:pt idx="1">
+                  <c:v>Q3 2024</c:v>
+                </c:pt>
+                <c:pt idx="2">
+                  <c:v>Q2 2024</c:v>
+                </c:pt>
+                <c:pt idx="3">
                   <c:v>Q1 2024</c:v>
-                </c:pt>
-                <c:pt idx="1">
-                  <c:v>Q2 2024</c:v>
-                </c:pt>
-                <c:pt idx="2">
-                  <c:v>Q3 2024</c:v>
-                </c:pt>
-                <c:pt idx="3">
-                  <c:v>Q4 2024</c:v>
                 </c:pt>
                 <c:pt idx="4">
                   <c:v>0</c:v>
                 </c:pt>
                 <c:pt idx="5">
-                  <c:v>0</c:v>
-                </c:pt>
-                <c:pt idx="6">
-                  <c:v>0</c:v>
-                </c:pt>
-                <c:pt idx="7">
-                  <c:v>0</c:v>
-                </c:pt>
-                <c:pt idx="8">
-                  <c:v>0</c:v>
-                </c:pt>
-                <c:pt idx="9">
-                  <c:v>0</c:v>
-                </c:pt>
-                <c:pt idx="10">
-                  <c:v>0</c:v>
-                </c:pt>
-                <c:pt idx="11">
-                  <c:v>0</c:v>
-                </c:pt>
-                <c:pt idx="12">
-                  <c:v>0</c:v>
-                </c:pt>
-                <c:pt idx="13">
-                  <c:v>0</c:v>
+                  <c:v>Other</c:v>
                 </c:pt>
               </c:strCache>
             </c:strRef>
           </c:cat>
           <c:val>
             <c:numRef>
-              <c:f>Sheet1!$D$2:$D$15</c:f>
+              <c:f>Sheet1!$D$2:$D$7</c:f>
               <c:numCache>
                 <c:formatCode>General</c:formatCode>
-                <c:ptCount val="14"/>
+                <c:ptCount val="6"/>
                 <c:pt idx="0">
+                  <c:v>1264000.0</c:v>
+                </c:pt>
+                <c:pt idx="1">
+                  <c:v>1136000.0</c:v>
+                </c:pt>
+                <c:pt idx="2">
+                  <c:v>1080000.0</c:v>
+                </c:pt>
+                <c:pt idx="3">
                   <c:v>960000.0</c:v>
-                </c:pt>
-                <c:pt idx="1">
-                  <c:v>1080000.0</c:v>
-                </c:pt>
-                <c:pt idx="2">
-                  <c:v>1136000.0</c:v>
-                </c:pt>
-                <c:pt idx="3">
-                  <c:v>1264000.0</c:v>
                 </c:pt>
                 <c:pt idx="4">
                   <c:v>0.0</c:v>
                 </c:pt>
                 <c:pt idx="5">
-                  <c:v>0.0</c:v>
-                </c:pt>
-                <c:pt idx="6">
-                  <c:v>0.0</c:v>
-                </c:pt>
-                <c:pt idx="7">
-                  <c:v>0.0</c:v>
-                </c:pt>
-                <c:pt idx="8">
-                  <c:v>0.0</c:v>
-                </c:pt>
-                <c:pt idx="9">
-                  <c:v>0.0</c:v>
-                </c:pt>
-                <c:pt idx="10">
-                  <c:v>0.0</c:v>
-                </c:pt>
-                <c:pt idx="11">
-                  <c:v>0.0</c:v>
-                </c:pt>
-                <c:pt idx="12">
-                  <c:v>0.0</c:v>
-                </c:pt>
-                <c:pt idx="13">
                   <c:v>0.0</c:v>
                 </c:pt>
               </c:numCache>
@@ -509,62 +429,59 @@
               </c:strCache>
             </c:strRef>
           </c:tx>
+          <c:dLbls>
+            <c:numFmt formatCode="#,##0" sourceLinked="0"/>
+            <c:txPr>
+              <a:bodyPr/>
+              <a:lstStyle/>
+              <a:p>
+                <a:pPr>
+                  <a:defRPr sz="1000">
+                    <a:latin typeface="Segoe UI"/>
+                  </a:defRPr>
+                </a:pPr>
+              </a:p>
+            </c:txPr>
+            <c:showLegendKey val="0"/>
+            <c:showVal val="0"/>
+            <c:showCatName val="0"/>
+            <c:showSerName val="0"/>
+            <c:showPercent val="0"/>
+            <c:showBubbleSize val="0"/>
+            <c:showLeaderLines val="1"/>
+          </c:dLbls>
           <c:cat>
             <c:strRef>
-              <c:f>Sheet1!$A$2:$A$15</c:f>
+              <c:f>Sheet1!$A$2:$A$7</c:f>
               <c:strCache>
-                <c:ptCount val="14"/>
+                <c:ptCount val="6"/>
                 <c:pt idx="0">
+                  <c:v>Q4 2024</c:v>
+                </c:pt>
+                <c:pt idx="1">
+                  <c:v>Q3 2024</c:v>
+                </c:pt>
+                <c:pt idx="2">
+                  <c:v>Q2 2024</c:v>
+                </c:pt>
+                <c:pt idx="3">
                   <c:v>Q1 2024</c:v>
-                </c:pt>
-                <c:pt idx="1">
-                  <c:v>Q2 2024</c:v>
-                </c:pt>
-                <c:pt idx="2">
-                  <c:v>Q3 2024</c:v>
-                </c:pt>
-                <c:pt idx="3">
-                  <c:v>Q4 2024</c:v>
                 </c:pt>
                 <c:pt idx="4">
                   <c:v>0</c:v>
                 </c:pt>
                 <c:pt idx="5">
-                  <c:v>0</c:v>
-                </c:pt>
-                <c:pt idx="6">
-                  <c:v>0</c:v>
-                </c:pt>
-                <c:pt idx="7">
-                  <c:v>0</c:v>
-                </c:pt>
-                <c:pt idx="8">
-                  <c:v>0</c:v>
-                </c:pt>
-                <c:pt idx="9">
-                  <c:v>0</c:v>
-                </c:pt>
-                <c:pt idx="10">
-                  <c:v>0</c:v>
-                </c:pt>
-                <c:pt idx="11">
-                  <c:v>0</c:v>
-                </c:pt>
-                <c:pt idx="12">
-                  <c:v>0</c:v>
-                </c:pt>
-                <c:pt idx="13">
-                  <c:v>0</c:v>
+                  <c:v>Other</c:v>
                 </c:pt>
               </c:strCache>
             </c:strRef>
           </c:cat>
           <c:val>
             <c:numRef>
-              <c:f>Sheet1!$E$2:$E$15</c:f>
+              <c:f>Sheet1!$E$2:$E$7</c:f>
               <c:numCache>
                 <c:formatCode>General</c:formatCode>
-                <c:ptCount val="14"/>
+                <c:ptCount val="6"/>
                 <c:pt idx="0">
                   <c:v>0.0</c:v>
                 </c:pt>
@@ -581,147 +498,7 @@
                   <c:v>45.0</c:v>
                 </c:pt>
                 <c:pt idx="5">
-                  <c:v>30.0</c:v>
-                </c:pt>
-                <c:pt idx="6">
-                  <c:v>15.0</c:v>
-                </c:pt>
-                <c:pt idx="7">
-                  <c:v>5.0</c:v>
-                </c:pt>
-                <c:pt idx="8">
-                  <c:v>5.0</c:v>
-                </c:pt>
-                <c:pt idx="9">
-                  <c:v>0.0</c:v>
-                </c:pt>
-                <c:pt idx="10">
-                  <c:v>0.0</c:v>
-                </c:pt>
-                <c:pt idx="11">
-                  <c:v>0.0</c:v>
-                </c:pt>
-                <c:pt idx="12">
-                  <c:v>0.0</c:v>
-                </c:pt>
-                <c:pt idx="13">
-                  <c:v>0.0</c:v>
-                </c:pt>
-              </c:numCache>
-            </c:numRef>
-          </c:val>
-        </c:ser>
-        <c:ser>
-          <c:idx val="4"/>
-          <c:order val="4"/>
-          <c:tx>
-            <c:strRef>
-              <c:f>Sheet1!$F$1</c:f>
-              <c:strCache>
-                <c:ptCount val="1"/>
-                <c:pt idx="0">
-                  <c:v>Sales</c:v>
-                </c:pt>
-              </c:strCache>
-            </c:strRef>
-          </c:tx>
-          <c:cat>
-            <c:strRef>
-              <c:f>Sheet1!$A$2:$A$15</c:f>
-              <c:strCache>
-                <c:ptCount val="14"/>
-                <c:pt idx="0">
-                  <c:v>Q1 2024</c:v>
-                </c:pt>
-                <c:pt idx="1">
-                  <c:v>Q2 2024</c:v>
-                </c:pt>
-                <c:pt idx="2">
-                  <c:v>Q3 2024</c:v>
-                </c:pt>
-                <c:pt idx="3">
-                  <c:v>Q4 2024</c:v>
-                </c:pt>
-                <c:pt idx="4">
-                  <c:v>0</c:v>
-                </c:pt>
-                <c:pt idx="5">
-                  <c:v>0</c:v>
-                </c:pt>
-                <c:pt idx="6">
-                  <c:v>0</c:v>
-                </c:pt>
-                <c:pt idx="7">
-                  <c:v>0</c:v>
-                </c:pt>
-                <c:pt idx="8">
-                  <c:v>0</c:v>
-                </c:pt>
-                <c:pt idx="9">
-                  <c:v>0</c:v>
-                </c:pt>
-                <c:pt idx="10">
-                  <c:v>0</c:v>
-                </c:pt>
-                <c:pt idx="11">
-                  <c:v>0</c:v>
-                </c:pt>
-                <c:pt idx="12">
-                  <c:v>0</c:v>
-                </c:pt>
-                <c:pt idx="13">
-                  <c:v>0</c:v>
-                </c:pt>
-              </c:strCache>
-            </c:strRef>
-          </c:cat>
-          <c:val>
-            <c:numRef>
-              <c:f>Sheet1!$F$2:$F$15</c:f>
-              <c:numCache>
-                <c:formatCode>General</c:formatCode>
-                <c:ptCount val="14"/>
-                <c:pt idx="0">
-                  <c:v>0.0</c:v>
-                </c:pt>
-                <c:pt idx="1">
-                  <c:v>0.0</c:v>
-                </c:pt>
-                <c:pt idx="2">
-                  <c:v>0.0</c:v>
-                </c:pt>
-                <c:pt idx="3">
-                  <c:v>0.0</c:v>
-                </c:pt>
-                <c:pt idx="4">
-                  <c:v>0.0</c:v>
-                </c:pt>
-                <c:pt idx="5">
-                  <c:v>0.0</c:v>
-                </c:pt>
-                <c:pt idx="6">
-                  <c:v>0.0</c:v>
-                </c:pt>
-                <c:pt idx="7">
-                  <c:v>0.0</c:v>
-                </c:pt>
-                <c:pt idx="8">
-                  <c:v>0.0</c:v>
-                </c:pt>
-                <c:pt idx="9">
-                  <c:v>850000.0</c:v>
-                </c:pt>
-                <c:pt idx="10">
-                  <c:v>720000.0</c:v>
-                </c:pt>
-                <c:pt idx="11">
-                  <c:v>650000.0</c:v>
-                </c:pt>
-                <c:pt idx="12">
-                  <c:v>480000.0</c:v>
-                </c:pt>
-                <c:pt idx="13">
-                  <c:v>320000.0</c:v>
+                  <c:v>55.0</c:v>
                 </c:pt>
               </c:numCache>
             </c:numRef>
@@ -740,6 +517,15 @@
         <c:majorTickMark val="out"/>
         <c:minorTickMark val="none"/>
         <c:tickLblPos val="nextTo"/>
+        <c:txPr>
+          <a:bodyPr/>
+          <a:lstStyle/>
+          <a:p>
+            <a:pPr>
+              <a:defRPr/>
+            </a:pPr>
+          </a:p>
+        </c:txPr>
         <c:crossAx val="-2113994440"/>
         <c:crosses val="autoZero"/>
         <c:auto val="1"/>
@@ -749,10 +535,13 @@
       </c:catAx>
       <c:valAx>
         <c:axId val="-2113994440"/>
-        <c:scaling/>
+        <c:scaling>
+          <c:min val="0.0"/>
+        </c:scaling>
         <c:delete val="0"/>
         <c:axPos val="l"/>
         <c:majorGridlines/>
+        <c:numFmt formatCode="#,##0" sourceLinked="0"/>
         <c:majorTickMark val="out"/>
         <c:minorTickMark val="none"/>
         <c:tickLblPos val="nextTo"/>
@@ -760,18 +549,6 @@
         <c:crosses val="autoZero"/>
       </c:valAx>
     </c:plotArea>
-    <c:legend>
-      <c:legendPos val="b"/>
-      <c:txPr>
-        <a:bodyPr/>
-        <a:lstStyle/>
-        <a:p>
-          <a:pPr>
-            <a:defRPr sz="1000"/>
-          </a:pPr>
-        </a:p>
-      </c:txPr>
-    </c:legend>
     <c:dispBlanksAs val="gap"/>
   </c:chart>
   <c:txPr>
@@ -802,10 +579,11 @@
           <a:lstStyle/>
           <a:p>
             <a:pPr>
-              <a:defRPr sz="1800" b="1">
+              <a:defRPr sz="3000" b="1">
                 <a:solidFill>
-                  <a:srgbClr val="000000"/>
+                  <a:srgbClr val="004F9E"/>
                 </a:solidFill>
+                <a:latin typeface="Segoe UI"/>
               </a:defRPr>
             </a:pPr>
             <a:r>
@@ -837,12 +615,15 @@
             </c:strRef>
           </c:tx>
           <c:dLbls>
+            <c:numFmt formatCode="0.0%" sourceLinked="0"/>
             <c:txPr>
               <a:bodyPr/>
               <a:lstStyle/>
               <a:p>
                 <a:pPr>
-                  <a:defRPr sz="1000" b="1"/>
+                  <a:defRPr sz="1000" b="1">
+                    <a:latin typeface="Segoe UI"/>
+                  </a:defRPr>
                 </a:pPr>
               </a:p>
             </c:txPr>
@@ -970,18 +751,9 @@
       </c:doughnutChart>
     </c:plotArea>
     <c:legend>
-      <c:legendPos val="b"/>
+      <c:legendPos val="r"/>
       <c:layout/>
       <c:overlay val="0"/>
-      <c:txPr>
-        <a:bodyPr/>
-        <a:lstStyle/>
-        <a:p>
-          <a:pPr>
-            <a:defRPr sz="1000"/>
-          </a:pPr>
-        </a:p>
-      </c:txPr>
     </c:legend>
     <c:plotVisOnly val="1"/>
     <c:dispBlanksAs val="gap"/>
@@ -1014,10 +786,11 @@
           <a:lstStyle/>
           <a:p>
             <a:pPr>
-              <a:defRPr sz="1800" b="1">
+              <a:defRPr sz="3000" b="1">
                 <a:solidFill>
-                  <a:srgbClr val="000000"/>
+                  <a:srgbClr val="004F9E"/>
                 </a:solidFill>
+                <a:latin typeface="Segoe UI"/>
               </a:defRPr>
             </a:pPr>
             <a:r>
@@ -1052,7 +825,7 @@
             <c:idx val="0"/>
             <c:spPr>
               <a:solidFill>
-                <a:srgbClr val="228B22"/>
+                <a:srgbClr val="16A085"/>
               </a:solidFill>
             </c:spPr>
           </c:dPt>
@@ -1060,7 +833,7 @@
             <c:idx val="1"/>
             <c:spPr>
               <a:solidFill>
-                <a:srgbClr val="228B22"/>
+                <a:srgbClr val="16A085"/>
               </a:solidFill>
             </c:spPr>
           </c:dPt>
@@ -1068,7 +841,7 @@
             <c:idx val="2"/>
             <c:spPr>
               <a:solidFill>
-                <a:srgbClr val="228B22"/>
+                <a:srgbClr val="16A085"/>
               </a:solidFill>
             </c:spPr>
           </c:dPt>
@@ -1076,7 +849,7 @@
             <c:idx val="3"/>
             <c:spPr>
               <a:solidFill>
-                <a:srgbClr val="228B22"/>
+                <a:srgbClr val="16A085"/>
               </a:solidFill>
             </c:spPr>
           </c:dPt>
@@ -1135,6 +908,15 @@
         <c:majorTickMark val="out"/>
         <c:minorTickMark val="none"/>
         <c:tickLblPos val="nextTo"/>
+        <c:txPr>
+          <a:bodyPr/>
+          <a:lstStyle/>
+          <a:p>
+            <a:pPr>
+              <a:defRPr/>
+            </a:pPr>
+          </a:p>
+        </c:txPr>
         <c:crossAx val="-2113994440"/>
         <c:crosses val="autoZero"/>
         <c:auto val="1"/>
@@ -1148,6 +930,7 @@
         <c:delete val="0"/>
         <c:axPos val="l"/>
         <c:majorGridlines/>
+        <c:numFmt formatCode="#,##0" sourceLinked="0"/>
         <c:majorTickMark val="out"/>
         <c:minorTickMark val="none"/>
         <c:tickLblPos val="nextTo"/>
@@ -1155,18 +938,6 @@
         <c:crosses val="autoZero"/>
       </c:valAx>
     </c:plotArea>
-    <c:legend>
-      <c:legendPos val="b"/>
-      <c:txPr>
-        <a:bodyPr/>
-        <a:lstStyle/>
-        <a:p>
-          <a:pPr>
-            <a:defRPr sz="1000"/>
-          </a:pPr>
-        </a:p>
-      </c:txPr>
-    </c:legend>
     <c:dispBlanksAs val="gap"/>
   </c:chart>
   <c:txPr>
@@ -1196,14 +967,15 @@
           <a:lstStyle/>
           <a:p>
             <a:pPr>
-              <a:defRPr sz="1800" b="1">
+              <a:defRPr sz="3000" b="1">
                 <a:solidFill>
-                  <a:srgbClr val="000000"/>
+                  <a:srgbClr val="004F9E"/>
                 </a:solidFill>
-              </a:defRPr>
-            </a:pPr>
-            <a:r>
-              <a:t>Comparison Analysis</a:t>
+                <a:latin typeface="Segoe UI"/>
+              </a:defRPr>
+            </a:pPr>
+            <a:r>
+              <a:t>Rankings</a:t>
             </a:r>
           </a:p>
         </c:rich>
@@ -1230,79 +1002,76 @@
               </c:strCache>
             </c:strRef>
           </c:tx>
+          <c:dLbls>
+            <c:numFmt formatCode="#,##0" sourceLinked="0"/>
+            <c:txPr>
+              <a:bodyPr/>
+              <a:lstStyle/>
+              <a:p>
+                <a:pPr>
+                  <a:defRPr sz="1000">
+                    <a:latin typeface="Segoe UI"/>
+                  </a:defRPr>
+                </a:pPr>
+              </a:p>
+            </c:txPr>
+            <c:showLegendKey val="0"/>
+            <c:showVal val="0"/>
+            <c:showCatName val="0"/>
+            <c:showSerName val="0"/>
+            <c:showPercent val="0"/>
+            <c:showBubbleSize val="0"/>
+            <c:showLeaderLines val="1"/>
+          </c:dLbls>
           <c:cat>
             <c:strRef>
-              <c:f>Sheet1!$A$2:$A$11</c:f>
+              <c:f>Sheet1!$A$2:$A$7</c:f>
               <c:strCache>
-                <c:ptCount val="10"/>
+                <c:ptCount val="6"/>
                 <c:pt idx="0">
+                  <c:v>Other</c:v>
+                </c:pt>
+                <c:pt idx="1">
+                  <c:v>0</c:v>
+                </c:pt>
+                <c:pt idx="2">
+                  <c:v>Q1 2024</c:v>
+                </c:pt>
+                <c:pt idx="3">
+                  <c:v>Q2 2024</c:v>
+                </c:pt>
+                <c:pt idx="4">
+                  <c:v>Q3 2024</c:v>
+                </c:pt>
+                <c:pt idx="5">
                   <c:v>Q4 2024</c:v>
-                </c:pt>
-                <c:pt idx="1">
-                  <c:v>Q3 2024</c:v>
-                </c:pt>
-                <c:pt idx="2">
-                  <c:v>Q2 2024</c:v>
-                </c:pt>
-                <c:pt idx="3">
-                  <c:v>Q1 2024</c:v>
-                </c:pt>
-                <c:pt idx="4">
-                  <c:v>0</c:v>
-                </c:pt>
-                <c:pt idx="5">
-                  <c:v>0</c:v>
-                </c:pt>
-                <c:pt idx="6">
-                  <c:v>0</c:v>
-                </c:pt>
-                <c:pt idx="7">
-                  <c:v>0</c:v>
-                </c:pt>
-                <c:pt idx="8">
-                  <c:v>0</c:v>
-                </c:pt>
-                <c:pt idx="9">
-                  <c:v>0</c:v>
                 </c:pt>
               </c:strCache>
             </c:strRef>
           </c:cat>
           <c:val>
             <c:numRef>
-              <c:f>Sheet1!$B$2:$B$11</c:f>
+              <c:f>Sheet1!$B$2:$B$7</c:f>
               <c:numCache>
                 <c:formatCode>General</c:formatCode>
-                <c:ptCount val="10"/>
+                <c:ptCount val="6"/>
                 <c:pt idx="0">
+                  <c:v>0.0</c:v>
+                </c:pt>
+                <c:pt idx="1">
+                  <c:v>0.0</c:v>
+                </c:pt>
+                <c:pt idx="2">
+                  <c:v>1200000.0</c:v>
+                </c:pt>
+                <c:pt idx="3">
+                  <c:v>1350000.0</c:v>
+                </c:pt>
+                <c:pt idx="4">
+                  <c:v>1420000.0</c:v>
+                </c:pt>
+                <c:pt idx="5">
                   <c:v>1580000.0</c:v>
-                </c:pt>
-                <c:pt idx="1">
-                  <c:v>1420000.0</c:v>
-                </c:pt>
-                <c:pt idx="2">
-                  <c:v>1350000.0</c:v>
-                </c:pt>
-                <c:pt idx="3">
-                  <c:v>1200000.0</c:v>
-                </c:pt>
-                <c:pt idx="4">
-                  <c:v>0.0</c:v>
-                </c:pt>
-                <c:pt idx="5">
-                  <c:v>0.0</c:v>
-                </c:pt>
-                <c:pt idx="6">
-                  <c:v>0.0</c:v>
-                </c:pt>
-                <c:pt idx="7">
-                  <c:v>0.0</c:v>
-                </c:pt>
-                <c:pt idx="8">
-                  <c:v>0.0</c:v>
-                </c:pt>
-                <c:pt idx="9">
-                  <c:v>0.0</c:v>
                 </c:pt>
               </c:numCache>
             </c:numRef>
@@ -1322,79 +1091,76 @@
               </c:strCache>
             </c:strRef>
           </c:tx>
+          <c:dLbls>
+            <c:numFmt formatCode="#,##0" sourceLinked="0"/>
+            <c:txPr>
+              <a:bodyPr/>
+              <a:lstStyle/>
+              <a:p>
+                <a:pPr>
+                  <a:defRPr sz="1000">
+                    <a:latin typeface="Segoe UI"/>
+                  </a:defRPr>
+                </a:pPr>
+              </a:p>
+            </c:txPr>
+            <c:showLegendKey val="0"/>
+            <c:showVal val="0"/>
+            <c:showCatName val="0"/>
+            <c:showSerName val="0"/>
+            <c:showPercent val="0"/>
+            <c:showBubbleSize val="0"/>
+            <c:showLeaderLines val="1"/>
+          </c:dLbls>
           <c:cat>
             <c:strRef>
-              <c:f>Sheet1!$A$2:$A$11</c:f>
+              <c:f>Sheet1!$A$2:$A$7</c:f>
               <c:strCache>
-                <c:ptCount val="10"/>
+                <c:ptCount val="6"/>
                 <c:pt idx="0">
+                  <c:v>Other</c:v>
+                </c:pt>
+                <c:pt idx="1">
+                  <c:v>0</c:v>
+                </c:pt>
+                <c:pt idx="2">
+                  <c:v>Q1 2024</c:v>
+                </c:pt>
+                <c:pt idx="3">
+                  <c:v>Q2 2024</c:v>
+                </c:pt>
+                <c:pt idx="4">
+                  <c:v>Q3 2024</c:v>
+                </c:pt>
+                <c:pt idx="5">
                   <c:v>Q4 2024</c:v>
-                </c:pt>
-                <c:pt idx="1">
-                  <c:v>Q3 2024</c:v>
-                </c:pt>
-                <c:pt idx="2">
-                  <c:v>Q2 2024</c:v>
-                </c:pt>
-                <c:pt idx="3">
-                  <c:v>Q1 2024</c:v>
-                </c:pt>
-                <c:pt idx="4">
-                  <c:v>0</c:v>
-                </c:pt>
-                <c:pt idx="5">
-                  <c:v>0</c:v>
-                </c:pt>
-                <c:pt idx="6">
-                  <c:v>0</c:v>
-                </c:pt>
-                <c:pt idx="7">
-                  <c:v>0</c:v>
-                </c:pt>
-                <c:pt idx="8">
-                  <c:v>0</c:v>
-                </c:pt>
-                <c:pt idx="9">
-                  <c:v>0</c:v>
                 </c:pt>
               </c:strCache>
             </c:strRef>
           </c:cat>
           <c:val>
             <c:numRef>
-              <c:f>Sheet1!$C$2:$C$11</c:f>
+              <c:f>Sheet1!$C$2:$C$7</c:f>
               <c:numCache>
                 <c:formatCode>General</c:formatCode>
-                <c:ptCount val="10"/>
+                <c:ptCount val="6"/>
                 <c:pt idx="0">
+                  <c:v>0.0</c:v>
+                </c:pt>
+                <c:pt idx="1">
+                  <c:v>0.0</c:v>
+                </c:pt>
+                <c:pt idx="2">
+                  <c:v>240000.0</c:v>
+                </c:pt>
+                <c:pt idx="3">
+                  <c:v>270000.0</c:v>
+                </c:pt>
+                <c:pt idx="4">
+                  <c:v>284000.0</c:v>
+                </c:pt>
+                <c:pt idx="5">
                   <c:v>316000.0</c:v>
-                </c:pt>
-                <c:pt idx="1">
-                  <c:v>284000.0</c:v>
-                </c:pt>
-                <c:pt idx="2">
-                  <c:v>270000.0</c:v>
-                </c:pt>
-                <c:pt idx="3">
-                  <c:v>240000.0</c:v>
-                </c:pt>
-                <c:pt idx="4">
-                  <c:v>0.0</c:v>
-                </c:pt>
-                <c:pt idx="5">
-                  <c:v>0.0</c:v>
-                </c:pt>
-                <c:pt idx="6">
-                  <c:v>0.0</c:v>
-                </c:pt>
-                <c:pt idx="7">
-                  <c:v>0.0</c:v>
-                </c:pt>
-                <c:pt idx="8">
-                  <c:v>0.0</c:v>
-                </c:pt>
-                <c:pt idx="9">
-                  <c:v>0.0</c:v>
                 </c:pt>
               </c:numCache>
             </c:numRef>
@@ -1414,78 +1180,164 @@
               </c:strCache>
             </c:strRef>
           </c:tx>
+          <c:dLbls>
+            <c:numFmt formatCode="#,##0" sourceLinked="0"/>
+            <c:txPr>
+              <a:bodyPr/>
+              <a:lstStyle/>
+              <a:p>
+                <a:pPr>
+                  <a:defRPr sz="1000">
+                    <a:latin typeface="Segoe UI"/>
+                  </a:defRPr>
+                </a:pPr>
+              </a:p>
+            </c:txPr>
+            <c:showLegendKey val="0"/>
+            <c:showVal val="0"/>
+            <c:showCatName val="0"/>
+            <c:showSerName val="0"/>
+            <c:showPercent val="0"/>
+            <c:showBubbleSize val="0"/>
+            <c:showLeaderLines val="1"/>
+          </c:dLbls>
           <c:cat>
             <c:strRef>
-              <c:f>Sheet1!$A$2:$A$11</c:f>
+              <c:f>Sheet1!$A$2:$A$7</c:f>
               <c:strCache>
-                <c:ptCount val="10"/>
+                <c:ptCount val="6"/>
                 <c:pt idx="0">
+                  <c:v>Other</c:v>
+                </c:pt>
+                <c:pt idx="1">
+                  <c:v>0</c:v>
+                </c:pt>
+                <c:pt idx="2">
+                  <c:v>Q1 2024</c:v>
+                </c:pt>
+                <c:pt idx="3">
+                  <c:v>Q2 2024</c:v>
+                </c:pt>
+                <c:pt idx="4">
+                  <c:v>Q3 2024</c:v>
+                </c:pt>
+                <c:pt idx="5">
                   <c:v>Q4 2024</c:v>
-                </c:pt>
-                <c:pt idx="1">
-                  <c:v>Q3 2024</c:v>
-                </c:pt>
-                <c:pt idx="2">
-                  <c:v>Q2 2024</c:v>
-                </c:pt>
-                <c:pt idx="3">
-                  <c:v>Q1 2024</c:v>
-                </c:pt>
-                <c:pt idx="4">
-                  <c:v>0</c:v>
-                </c:pt>
-                <c:pt idx="5">
-                  <c:v>0</c:v>
-                </c:pt>
-                <c:pt idx="6">
-                  <c:v>0</c:v>
-                </c:pt>
-                <c:pt idx="7">
-                  <c:v>0</c:v>
-                </c:pt>
-                <c:pt idx="8">
-                  <c:v>0</c:v>
-                </c:pt>
-                <c:pt idx="9">
-                  <c:v>0</c:v>
                 </c:pt>
               </c:strCache>
             </c:strRef>
           </c:cat>
           <c:val>
             <c:numRef>
-              <c:f>Sheet1!$D$2:$D$11</c:f>
+              <c:f>Sheet1!$D$2:$D$7</c:f>
               <c:numCache>
                 <c:formatCode>General</c:formatCode>
-                <c:ptCount val="10"/>
+                <c:ptCount val="6"/>
                 <c:pt idx="0">
+                  <c:v>0.0</c:v>
+                </c:pt>
+                <c:pt idx="1">
+                  <c:v>0.0</c:v>
+                </c:pt>
+                <c:pt idx="2">
+                  <c:v>960000.0</c:v>
+                </c:pt>
+                <c:pt idx="3">
+                  <c:v>1080000.0</c:v>
+                </c:pt>
+                <c:pt idx="4">
+                  <c:v>1136000.0</c:v>
+                </c:pt>
+                <c:pt idx="5">
                   <c:v>1264000.0</c:v>
                 </c:pt>
+              </c:numCache>
+            </c:numRef>
+          </c:val>
+        </c:ser>
+        <c:ser>
+          <c:idx val="3"/>
+          <c:order val="3"/>
+          <c:tx>
+            <c:strRef>
+              <c:f>Sheet1!$E$1</c:f>
+              <c:strCache>
+                <c:ptCount val="1"/>
+                <c:pt idx="0">
+                  <c:v>Allocation %</c:v>
+                </c:pt>
+              </c:strCache>
+            </c:strRef>
+          </c:tx>
+          <c:dLbls>
+            <c:numFmt formatCode="#,##0" sourceLinked="0"/>
+            <c:txPr>
+              <a:bodyPr/>
+              <a:lstStyle/>
+              <a:p>
+                <a:pPr>
+                  <a:defRPr sz="1000">
+                    <a:latin typeface="Segoe UI"/>
+                  </a:defRPr>
+                </a:pPr>
+              </a:p>
+            </c:txPr>
+            <c:showLegendKey val="0"/>
+            <c:showVal val="0"/>
+            <c:showCatName val="0"/>
+            <c:showSerName val="0"/>
+            <c:showPercent val="0"/>
+            <c:showBubbleSize val="0"/>
+            <c:showLeaderLines val="1"/>
+          </c:dLbls>
+          <c:cat>
+            <c:strRef>
+              <c:f>Sheet1!$A$2:$A$7</c:f>
+              <c:strCache>
+                <c:ptCount val="6"/>
+                <c:pt idx="0">
+                  <c:v>Other</c:v>
+                </c:pt>
                 <c:pt idx="1">
-                  <c:v>1136000.0</c:v>
+                  <c:v>0</c:v>
                 </c:pt>
                 <c:pt idx="2">
-                  <c:v>1080000.0</c:v>
+                  <c:v>Q1 2024</c:v>
                 </c:pt>
                 <c:pt idx="3">
-                  <c:v>960000.0</c:v>
+                  <c:v>Q2 2024</c:v>
+                </c:pt>
+                <c:pt idx="4">
+                  <c:v>Q3 2024</c:v>
+                </c:pt>
+                <c:pt idx="5">
+                  <c:v>Q4 2024</c:v>
+                </c:pt>
+              </c:strCache>
+            </c:strRef>
+          </c:cat>
+          <c:val>
+            <c:numRef>
+              <c:f>Sheet1!$E$2:$E$7</c:f>
+              <c:numCache>
+                <c:formatCode>General</c:formatCode>
+                <c:ptCount val="6"/>
+                <c:pt idx="0">
+                  <c:v>55.0</c:v>
+                </c:pt>
+                <c:pt idx="1">
+                  <c:v>45.0</c:v>
+                </c:pt>
+                <c:pt idx="2">
+                  <c:v>0.0</c:v>
+                </c:pt>
+                <c:pt idx="3">
+                  <c:v>0.0</c:v>
                 </c:pt>
                 <c:pt idx="4">
                   <c:v>0.0</c:v>
                 </c:pt>
                 <c:pt idx="5">
-                  <c:v>0.0</c:v>
-                </c:pt>
-                <c:pt idx="6">
-                  <c:v>0.0</c:v>
-                </c:pt>
-                <c:pt idx="7">
-                  <c:v>0.0</c:v>
-                </c:pt>
-                <c:pt idx="8">
-                  <c:v>0.0</c:v>
-                </c:pt>
-                <c:pt idx="9">
                   <c:v>0.0</c:v>
                 </c:pt>
               </c:numCache>
@@ -1505,6 +1357,15 @@
         <c:majorTickMark val="out"/>
         <c:minorTickMark val="none"/>
         <c:tickLblPos val="nextTo"/>
+        <c:txPr>
+          <a:bodyPr/>
+          <a:lstStyle/>
+          <a:p>
+            <a:pPr>
+              <a:defRPr/>
+            </a:pPr>
+          </a:p>
+        </c:txPr>
         <c:crossAx val="-2113994440"/>
         <c:crosses val="autoZero"/>
         <c:auto val="1"/>
@@ -1514,10 +1375,13 @@
       </c:catAx>
       <c:valAx>
         <c:axId val="-2113994440"/>
-        <c:scaling/>
+        <c:scaling>
+          <c:min val="0.0"/>
+        </c:scaling>
         <c:delete val="0"/>
         <c:axPos val="b"/>
         <c:majorGridlines/>
+        <c:numFmt formatCode="#,##0" sourceLinked="0"/>
         <c:majorTickMark val="out"/>
         <c:minorTickMark val="none"/>
         <c:tickLblPos val="nextTo"/>
@@ -1525,18 +1389,6 @@
         <c:crosses val="autoZero"/>
       </c:valAx>
     </c:plotArea>
-    <c:legend>
-      <c:legendPos val="b"/>
-      <c:txPr>
-        <a:bodyPr/>
-        <a:lstStyle/>
-        <a:p>
-          <a:pPr>
-            <a:defRPr sz="1000"/>
-          </a:pPr>
-        </a:p>
-      </c:txPr>
-    </c:legend>
     <c:dispBlanksAs val="gap"/>
   </c:chart>
   <c:txPr>
@@ -1567,10 +1419,11 @@
           <a:lstStyle/>
           <a:p>
             <a:pPr>
-              <a:defRPr sz="1800" b="1">
+              <a:defRPr sz="3000" b="1">
                 <a:solidFill>
-                  <a:srgbClr val="000000"/>
+                  <a:srgbClr val="004F9E"/>
                 </a:solidFill>
+                <a:latin typeface="Segoe UI"/>
               </a:defRPr>
             </a:pPr>
             <a:r>
@@ -1602,12 +1455,15 @@
             </c:strRef>
           </c:tx>
           <c:dLbls>
+            <c:numFmt formatCode="0.0%" sourceLinked="0"/>
             <c:txPr>
               <a:bodyPr/>
               <a:lstStyle/>
               <a:p>
                 <a:pPr>
-                  <a:defRPr sz="1000" b="1"/>
+                  <a:defRPr sz="1000" b="1">
+                    <a:latin typeface="Segoe UI"/>
+                  </a:defRPr>
                 </a:pPr>
               </a:p>
             </c:txPr>
@@ -1735,18 +1591,9 @@
       </c:doughnutChart>
     </c:plotArea>
     <c:legend>
-      <c:legendPos val="b"/>
+      <c:legendPos val="r"/>
       <c:layout/>
       <c:overlay val="0"/>
-      <c:txPr>
-        <a:bodyPr/>
-        <a:lstStyle/>
-        <a:p>
-          <a:pPr>
-            <a:defRPr sz="1000"/>
-          </a:pPr>
-        </a:p>
-      </c:txPr>
     </c:legend>
     <c:plotVisOnly val="1"/>
     <c:dispBlanksAs val="gap"/>
@@ -4790,7 +4637,11 @@
           <a:bodyPr rtlCol="0" anchor="ctr"/>
           <a:lstStyle/>
           <a:p>
-            <a:pPr algn="ctr"/>
+            <a:pPr algn="ctr">
+              <a:defRPr>
+                <a:latin typeface="Segoe UI"/>
+              </a:defRPr>
+            </a:pPr>
           </a:p>
         </p:txBody>
       </p:sp>
@@ -4833,7 +4684,11 @@
           <a:bodyPr rtlCol="0" anchor="ctr"/>
           <a:lstStyle/>
           <a:p>
-            <a:pPr algn="ctr"/>
+            <a:pPr algn="ctr">
+              <a:defRPr>
+                <a:latin typeface="Segoe UI"/>
+              </a:defRPr>
+            </a:pPr>
           </a:p>
         </p:txBody>
       </p:sp>
@@ -4878,7 +4733,11 @@
           <a:bodyPr rtlCol="0" anchor="ctr"/>
           <a:lstStyle/>
           <a:p>
-            <a:pPr algn="ctr"/>
+            <a:pPr algn="ctr">
+              <a:defRPr>
+                <a:latin typeface="Segoe UI"/>
+              </a:defRPr>
+            </a:pPr>
           </a:p>
         </p:txBody>
       </p:sp>
@@ -4909,6 +4768,7 @@
                 <a:solidFill>
                   <a:srgbClr val="C62828"/>
                 </a:solidFill>
+                <a:latin typeface="Segoe UI"/>
               </a:defRPr>
             </a:pPr>
             <a:r>
@@ -4944,6 +4804,7 @@
                 <a:solidFill>
                   <a:srgbClr val="FFFFFF"/>
                 </a:solidFill>
+                <a:latin typeface="Segoe UI"/>
               </a:defRPr>
             </a:pPr>
             <a:r>
@@ -4979,6 +4840,7 @@
                 <a:solidFill>
                   <a:srgbClr val="E53935"/>
                 </a:solidFill>
+                <a:latin typeface="Segoe UI"/>
               </a:defRPr>
             </a:pPr>
             <a:r>
@@ -5014,6 +4876,7 @@
                 <a:solidFill>
                   <a:srgbClr val="7F8C8D"/>
                 </a:solidFill>
+                <a:latin typeface="Segoe UI"/>
               </a:defRPr>
             </a:pPr>
             <a:r>
@@ -5049,6 +4912,7 @@
                 <a:solidFill>
                   <a:srgbClr val="E53935"/>
                 </a:solidFill>
+                <a:latin typeface="Segoe UI"/>
               </a:defRPr>
             </a:pPr>
             <a:r>
@@ -5099,7 +4963,11 @@
           <a:bodyPr rtlCol="0" anchor="ctr"/>
           <a:lstStyle/>
           <a:p>
-            <a:pPr algn="ctr"/>
+            <a:pPr algn="ctr">
+              <a:defRPr>
+                <a:latin typeface="Segoe UI"/>
+              </a:defRPr>
+            </a:pPr>
           </a:p>
         </p:txBody>
       </p:sp>
@@ -5160,7 +5028,11 @@
           <a:bodyPr rtlCol="0" anchor="ctr"/>
           <a:lstStyle/>
           <a:p>
-            <a:pPr algn="ctr"/>
+            <a:pPr algn="ctr">
+              <a:defRPr>
+                <a:latin typeface="Segoe UI"/>
+              </a:defRPr>
+            </a:pPr>
           </a:p>
         </p:txBody>
       </p:sp>
@@ -5191,6 +5063,7 @@
                 <a:solidFill>
                   <a:srgbClr val="FFFFFF"/>
                 </a:solidFill>
+                <a:latin typeface="Segoe UI"/>
               </a:defRPr>
             </a:pPr>
             <a:r>
@@ -5220,7 +5093,13 @@
             <a:spAutoFit/>
           </a:bodyPr>
           <a:lstStyle/>
-          <a:p/>
+          <a:p>
+            <a:pPr>
+              <a:defRPr>
+                <a:latin typeface="Segoe UI"/>
+              </a:defRPr>
+            </a:pPr>
+          </a:p>
           <a:p>
             <a:pPr algn="ctr">
               <a:spcAft>
@@ -5230,6 +5109,7 @@
                 <a:solidFill>
                   <a:srgbClr val="E53935"/>
                 </a:solidFill>
+                <a:latin typeface="Segoe UI"/>
               </a:defRPr>
             </a:pPr>
             <a:r>
@@ -5245,6 +5125,7 @@
                 <a:solidFill>
                   <a:srgbClr val="E53935"/>
                 </a:solidFill>
+                <a:latin typeface="Segoe UI"/>
               </a:defRPr>
             </a:pPr>
             <a:r>
@@ -5260,6 +5141,7 @@
                 <a:solidFill>
                   <a:srgbClr val="E53935"/>
                 </a:solidFill>
+                <a:latin typeface="Segoe UI"/>
               </a:defRPr>
             </a:pPr>
             <a:r>
@@ -5295,6 +5177,7 @@
                 <a:solidFill>
                   <a:srgbClr val="ECEFF1"/>
                 </a:solidFill>
+                <a:latin typeface="Segoe UI"/>
               </a:defRPr>
             </a:pPr>
             <a:r>
@@ -5348,6 +5231,7 @@
                 <a:solidFill>
                   <a:srgbClr val="C62828"/>
                 </a:solidFill>
+                <a:latin typeface="Segoe UI"/>
               </a:defRPr>
             </a:pPr>
             <a:r>
@@ -5395,7 +5279,11 @@
           <a:bodyPr rtlCol="0" anchor="ctr"/>
           <a:lstStyle/>
           <a:p>
-            <a:pPr algn="ctr"/>
+            <a:pPr algn="ctr">
+              <a:defRPr>
+                <a:latin typeface="Segoe UI"/>
+              </a:defRPr>
+            </a:pPr>
           </a:p>
         </p:txBody>
       </p:sp>
@@ -5429,6 +5317,7 @@
                 <a:solidFill>
                   <a:srgbClr val="34495E"/>
                 </a:solidFill>
+                <a:latin typeface="Segoe UI"/>
               </a:defRPr>
             </a:pPr>
             <a:r>
@@ -5497,7 +5386,11 @@
           <a:bodyPr rtlCol="0" anchor="ctr"/>
           <a:lstStyle/>
           <a:p>
-            <a:pPr algn="ctr"/>
+            <a:pPr algn="ctr">
+              <a:defRPr>
+                <a:latin typeface="Segoe UI"/>
+              </a:defRPr>
+            </a:pPr>
           </a:p>
         </p:txBody>
       </p:sp>
@@ -5531,6 +5424,7 @@
                 <a:solidFill>
                   <a:srgbClr val="34495E"/>
                 </a:solidFill>
+                <a:latin typeface="Segoe UI"/>
               </a:defRPr>
             </a:pPr>
             <a:r>
@@ -5599,7 +5493,11 @@
           <a:bodyPr rtlCol="0" anchor="ctr"/>
           <a:lstStyle/>
           <a:p>
-            <a:pPr algn="ctr"/>
+            <a:pPr algn="ctr">
+              <a:defRPr>
+                <a:latin typeface="Segoe UI"/>
+              </a:defRPr>
+            </a:pPr>
           </a:p>
         </p:txBody>
       </p:sp>
@@ -5633,6 +5531,7 @@
                 <a:solidFill>
                   <a:srgbClr val="34495E"/>
                 </a:solidFill>
+                <a:latin typeface="Segoe UI"/>
               </a:defRPr>
             </a:pPr>
             <a:r>
@@ -5706,7 +5605,11 @@
           <a:bodyPr rtlCol="0" anchor="ctr"/>
           <a:lstStyle/>
           <a:p>
-            <a:pPr algn="ctr"/>
+            <a:pPr algn="ctr">
+              <a:defRPr>
+                <a:latin typeface="Segoe UI"/>
+              </a:defRPr>
+            </a:pPr>
           </a:p>
         </p:txBody>
       </p:sp>
@@ -5740,6 +5643,7 @@
                 <a:solidFill>
                   <a:srgbClr val="34495E"/>
                 </a:solidFill>
+                <a:latin typeface="Segoe UI"/>
               </a:defRPr>
             </a:pPr>
             <a:r>
@@ -5808,7 +5712,11 @@
           <a:bodyPr rtlCol="0" anchor="ctr"/>
           <a:lstStyle/>
           <a:p>
-            <a:pPr algn="ctr"/>
+            <a:pPr algn="ctr">
+              <a:defRPr>
+                <a:latin typeface="Segoe UI"/>
+              </a:defRPr>
+            </a:pPr>
           </a:p>
         </p:txBody>
       </p:sp>
@@ -5842,6 +5750,7 @@
                 <a:solidFill>
                   <a:srgbClr val="34495E"/>
                 </a:solidFill>
+                <a:latin typeface="Segoe UI"/>
               </a:defRPr>
             </a:pPr>
             <a:r>
@@ -5913,6 +5822,7 @@
                 <a:solidFill>
                   <a:srgbClr val="C62828"/>
                 </a:solidFill>
+                <a:latin typeface="Segoe UI"/>
               </a:defRPr>
             </a:pPr>
             <a:r>
@@ -5947,6 +5857,9 @@
               <a:spcBef>
                 <a:spcPts val="1200"/>
               </a:spcBef>
+              <a:defRPr>
+                <a:latin typeface="Segoe UI"/>
+              </a:defRPr>
             </a:pPr>
             <a:r>
               <a:rPr sz="1800" b="1">
@@ -5970,6 +5883,9 @@
               <a:spcBef>
                 <a:spcPts val="1200"/>
               </a:spcBef>
+              <a:defRPr>
+                <a:latin typeface="Segoe UI"/>
+              </a:defRPr>
             </a:pPr>
             <a:r>
               <a:rPr sz="1800" b="1">
@@ -5993,6 +5909,9 @@
               <a:spcBef>
                 <a:spcPts val="1200"/>
               </a:spcBef>
+              <a:defRPr>
+                <a:latin typeface="Segoe UI"/>
+              </a:defRPr>
             </a:pPr>
             <a:r>
               <a:rPr sz="1800" b="1">
@@ -6016,6 +5935,9 @@
               <a:spcBef>
                 <a:spcPts val="1200"/>
               </a:spcBef>
+              <a:defRPr>
+                <a:latin typeface="Segoe UI"/>
+              </a:defRPr>
             </a:pPr>
             <a:r>
               <a:rPr sz="1800" b="1">
@@ -6039,6 +5961,9 @@
               <a:spcBef>
                 <a:spcPts val="1200"/>
               </a:spcBef>
+              <a:defRPr>
+                <a:latin typeface="Segoe UI"/>
+              </a:defRPr>
             </a:pPr>
             <a:r>
               <a:rPr sz="1800" b="1">
@@ -6100,7 +6025,11 @@
           <a:bodyPr rtlCol="0" anchor="ctr" wrap="square" lIns="182880" rIns="182880" tIns="91440"/>
           <a:lstStyle/>
           <a:p>
-            <a:pPr algn="ctr"/>
+            <a:pPr algn="ctr">
+              <a:defRPr>
+                <a:latin typeface="Segoe UI"/>
+              </a:defRPr>
+            </a:pPr>
             <a:r>
               <a:rPr sz="1400" b="1">
                 <a:solidFill>
@@ -6165,6 +6094,7 @@
                 <a:solidFill>
                   <a:srgbClr val="C62828"/>
                 </a:solidFill>
+                <a:latin typeface="Segoe UI"/>
               </a:defRPr>
             </a:pPr>
             <a:r>
@@ -6214,7 +6144,11 @@
           <a:bodyPr rtlCol="0" anchor="ctr"/>
           <a:lstStyle/>
           <a:p>
-            <a:pPr algn="ctr"/>
+            <a:pPr algn="ctr">
+              <a:defRPr>
+                <a:latin typeface="Segoe UI"/>
+              </a:defRPr>
+            </a:pPr>
           </a:p>
         </p:txBody>
       </p:sp>
@@ -6245,6 +6179,7 @@
                 <a:solidFill>
                   <a:srgbClr val="34495E"/>
                 </a:solidFill>
+                <a:latin typeface="Segoe UI"/>
               </a:defRPr>
             </a:pPr>
             <a:r>
@@ -6280,6 +6215,7 @@
                 <a:solidFill>
                   <a:srgbClr val="C62828"/>
                 </a:solidFill>
+                <a:latin typeface="Segoe UI"/>
               </a:defRPr>
             </a:pPr>
             <a:r>
@@ -6315,6 +6251,7 @@
                 <a:solidFill>
                   <a:srgbClr val="7F8C8D"/>
                 </a:solidFill>
+                <a:latin typeface="Segoe UI"/>
               </a:defRPr>
             </a:pPr>
             <a:r>
@@ -6364,7 +6301,11 @@
           <a:bodyPr rtlCol="0" anchor="ctr"/>
           <a:lstStyle/>
           <a:p>
-            <a:pPr algn="ctr"/>
+            <a:pPr algn="ctr">
+              <a:defRPr>
+                <a:latin typeface="Segoe UI"/>
+              </a:defRPr>
+            </a:pPr>
           </a:p>
         </p:txBody>
       </p:sp>
@@ -6395,6 +6336,7 @@
                 <a:solidFill>
                   <a:srgbClr val="34495E"/>
                 </a:solidFill>
+                <a:latin typeface="Segoe UI"/>
               </a:defRPr>
             </a:pPr>
             <a:r>
@@ -6430,6 +6372,7 @@
                 <a:solidFill>
                   <a:srgbClr val="C62828"/>
                 </a:solidFill>
+                <a:latin typeface="Segoe UI"/>
               </a:defRPr>
             </a:pPr>
             <a:r>
@@ -6465,6 +6408,7 @@
                 <a:solidFill>
                   <a:srgbClr val="7F8C8D"/>
                 </a:solidFill>
+                <a:latin typeface="Segoe UI"/>
               </a:defRPr>
             </a:pPr>
             <a:r>
@@ -6514,7 +6458,11 @@
           <a:bodyPr rtlCol="0" anchor="ctr"/>
           <a:lstStyle/>
           <a:p>
-            <a:pPr algn="ctr"/>
+            <a:pPr algn="ctr">
+              <a:defRPr>
+                <a:latin typeface="Segoe UI"/>
+              </a:defRPr>
+            </a:pPr>
           </a:p>
         </p:txBody>
       </p:sp>
@@ -6545,6 +6493,7 @@
                 <a:solidFill>
                   <a:srgbClr val="34495E"/>
                 </a:solidFill>
+                <a:latin typeface="Segoe UI"/>
               </a:defRPr>
             </a:pPr>
             <a:r>
@@ -6580,6 +6529,7 @@
                 <a:solidFill>
                   <a:srgbClr val="C62828"/>
                 </a:solidFill>
+                <a:latin typeface="Segoe UI"/>
               </a:defRPr>
             </a:pPr>
             <a:r>
@@ -6615,6 +6565,7 @@
                 <a:solidFill>
                   <a:srgbClr val="7F8C8D"/>
                 </a:solidFill>
+                <a:latin typeface="Segoe UI"/>
               </a:defRPr>
             </a:pPr>
             <a:r>
@@ -6664,7 +6615,11 @@
           <a:bodyPr rtlCol="0" anchor="ctr"/>
           <a:lstStyle/>
           <a:p>
-            <a:pPr algn="ctr"/>
+            <a:pPr algn="ctr">
+              <a:defRPr>
+                <a:latin typeface="Segoe UI"/>
+              </a:defRPr>
+            </a:pPr>
           </a:p>
         </p:txBody>
       </p:sp>
@@ -6695,6 +6650,7 @@
                 <a:solidFill>
                   <a:srgbClr val="34495E"/>
                 </a:solidFill>
+                <a:latin typeface="Segoe UI"/>
               </a:defRPr>
             </a:pPr>
             <a:r>
@@ -6730,6 +6686,7 @@
                 <a:solidFill>
                   <a:srgbClr val="C62828"/>
                 </a:solidFill>
+                <a:latin typeface="Segoe UI"/>
               </a:defRPr>
             </a:pPr>
             <a:r>
@@ -6765,6 +6722,7 @@
                 <a:solidFill>
                   <a:srgbClr val="7F8C8D"/>
                 </a:solidFill>
+                <a:latin typeface="Segoe UI"/>
               </a:defRPr>
             </a:pPr>
             <a:r>
@@ -6836,6 +6794,7 @@
                 <a:solidFill>
                   <a:srgbClr val="C62828"/>
                 </a:solidFill>
+                <a:latin typeface="Segoe UI"/>
               </a:defRPr>
             </a:pPr>
             <a:r>
@@ -6865,7 +6824,13 @@
             <a:spAutoFit/>
           </a:bodyPr>
           <a:lstStyle/>
-          <a:p/>
+          <a:p>
+            <a:pPr>
+              <a:defRPr>
+                <a:latin typeface="Segoe UI"/>
+              </a:defRPr>
+            </a:pPr>
+          </a:p>
           <a:p>
             <a:pPr>
               <a:spcAft>
@@ -6875,6 +6840,7 @@
                 <a:solidFill>
                   <a:srgbClr val="34495E"/>
                 </a:solidFill>
+                <a:latin typeface="Segoe UI"/>
               </a:defRPr>
             </a:pPr>
             <a:r>
@@ -6890,6 +6856,7 @@
                 <a:solidFill>
                   <a:srgbClr val="34495E"/>
                 </a:solidFill>
+                <a:latin typeface="Segoe UI"/>
               </a:defRPr>
             </a:pPr>
             <a:r>
@@ -6905,6 +6872,7 @@
                 <a:solidFill>
                   <a:srgbClr val="34495E"/>
                 </a:solidFill>
+                <a:latin typeface="Segoe UI"/>
               </a:defRPr>
             </a:pPr>
             <a:r>
@@ -6920,6 +6888,7 @@
                 <a:solidFill>
                   <a:srgbClr val="34495E"/>
                 </a:solidFill>
+                <a:latin typeface="Segoe UI"/>
               </a:defRPr>
             </a:pPr>
             <a:r>
@@ -6991,6 +6960,7 @@
                 <a:solidFill>
                   <a:srgbClr val="C62828"/>
                 </a:solidFill>
+                <a:latin typeface="Segoe UI"/>
               </a:defRPr>
             </a:pPr>
             <a:r>
@@ -7044,6 +7014,7 @@
                 <a:solidFill>
                   <a:srgbClr val="C62828"/>
                 </a:solidFill>
+                <a:latin typeface="Segoe UI"/>
               </a:defRPr>
             </a:pPr>
             <a:r>
@@ -7075,7 +7046,9 @@
           <a:lstStyle/>
           <a:p>
             <a:pPr>
-              <a:defRPr sz="1200"/>
+              <a:defRPr sz="1200">
+                <a:latin typeface="Segoe UI"/>
+              </a:defRPr>
             </a:pPr>
             <a:r>
               <a:t>Q4 2024</a:t>
@@ -7106,7 +7079,9 @@
           <a:lstStyle/>
           <a:p>
             <a:pPr algn="r">
-              <a:defRPr sz="1200" b="1"/>
+              <a:defRPr sz="1200" b="1">
+                <a:latin typeface="Segoe UI"/>
+              </a:defRPr>
             </a:pPr>
             <a:r>
               <a:t>28.5%</a:t>
@@ -7137,7 +7112,9 @@
           <a:lstStyle/>
           <a:p>
             <a:pPr>
-              <a:defRPr sz="1200"/>
+              <a:defRPr sz="1200">
+                <a:latin typeface="Segoe UI"/>
+              </a:defRPr>
             </a:pPr>
             <a:r>
               <a:t>Q3 2024</a:t>
@@ -7168,7 +7145,9 @@
           <a:lstStyle/>
           <a:p>
             <a:pPr algn="r">
-              <a:defRPr sz="1200" b="1"/>
+              <a:defRPr sz="1200" b="1">
+                <a:latin typeface="Segoe UI"/>
+              </a:defRPr>
             </a:pPr>
             <a:r>
               <a:t>25.6%</a:t>
@@ -7199,7 +7178,9 @@
           <a:lstStyle/>
           <a:p>
             <a:pPr>
-              <a:defRPr sz="1200"/>
+              <a:defRPr sz="1200">
+                <a:latin typeface="Segoe UI"/>
+              </a:defRPr>
             </a:pPr>
             <a:r>
               <a:t>Q2 2024</a:t>
@@ -7230,7 +7211,9 @@
           <a:lstStyle/>
           <a:p>
             <a:pPr algn="r">
-              <a:defRPr sz="1200" b="1"/>
+              <a:defRPr sz="1200" b="1">
+                <a:latin typeface="Segoe UI"/>
+              </a:defRPr>
             </a:pPr>
             <a:r>
               <a:t>24.3%</a:t>
@@ -7261,7 +7244,9 @@
           <a:lstStyle/>
           <a:p>
             <a:pPr>
-              <a:defRPr sz="1200"/>
+              <a:defRPr sz="1200">
+                <a:latin typeface="Segoe UI"/>
+              </a:defRPr>
             </a:pPr>
             <a:r>
               <a:t>Q1 2024</a:t>
@@ -7292,7 +7277,9 @@
           <a:lstStyle/>
           <a:p>
             <a:pPr algn="r">
-              <a:defRPr sz="1200" b="1"/>
+              <a:defRPr sz="1200" b="1">
+                <a:latin typeface="Segoe UI"/>
+              </a:defRPr>
             </a:pPr>
             <a:r>
               <a:t>21.6%</a:t>
@@ -7345,6 +7332,7 @@
                 <a:solidFill>
                   <a:srgbClr val="C62828"/>
                 </a:solidFill>
+                <a:latin typeface="Segoe UI"/>
               </a:defRPr>
             </a:pPr>
             <a:r>
@@ -7394,7 +7382,11 @@
           <a:bodyPr rtlCol="0" anchor="ctr"/>
           <a:lstStyle/>
           <a:p>
-            <a:pPr algn="ctr"/>
+            <a:pPr algn="ctr">
+              <a:defRPr>
+                <a:latin typeface="Segoe UI"/>
+              </a:defRPr>
+            </a:pPr>
           </a:p>
         </p:txBody>
       </p:sp>
@@ -7425,6 +7417,7 @@
                 <a:solidFill>
                   <a:srgbClr val="C62828"/>
                 </a:solidFill>
+                <a:latin typeface="Segoe UI"/>
               </a:defRPr>
             </a:pPr>
             <a:r>
@@ -7460,6 +7453,7 @@
                 <a:solidFill>
                   <a:srgbClr val="34495E"/>
                 </a:solidFill>
+                <a:latin typeface="Segoe UI"/>
               </a:defRPr>
             </a:pPr>
             <a:r>
@@ -7509,7 +7503,11 @@
           <a:bodyPr rtlCol="0" anchor="ctr"/>
           <a:lstStyle/>
           <a:p>
-            <a:pPr algn="ctr"/>
+            <a:pPr algn="ctr">
+              <a:defRPr>
+                <a:latin typeface="Segoe UI"/>
+              </a:defRPr>
+            </a:pPr>
           </a:p>
         </p:txBody>
       </p:sp>
@@ -7540,6 +7538,7 @@
                 <a:solidFill>
                   <a:srgbClr val="C62828"/>
                 </a:solidFill>
+                <a:latin typeface="Segoe UI"/>
               </a:defRPr>
             </a:pPr>
             <a:r>
@@ -7575,6 +7574,7 @@
                 <a:solidFill>
                   <a:srgbClr val="34495E"/>
                 </a:solidFill>
+                <a:latin typeface="Segoe UI"/>
               </a:defRPr>
             </a:pPr>
             <a:r>
@@ -7624,7 +7624,11 @@
           <a:bodyPr rtlCol="0" anchor="ctr"/>
           <a:lstStyle/>
           <a:p>
-            <a:pPr algn="ctr"/>
+            <a:pPr algn="ctr">
+              <a:defRPr>
+                <a:latin typeface="Segoe UI"/>
+              </a:defRPr>
+            </a:pPr>
           </a:p>
         </p:txBody>
       </p:sp>
@@ -7655,6 +7659,7 @@
                 <a:solidFill>
                   <a:srgbClr val="C62828"/>
                 </a:solidFill>
+                <a:latin typeface="Segoe UI"/>
               </a:defRPr>
             </a:pPr>
             <a:r>
@@ -7690,6 +7695,7 @@
                 <a:solidFill>
                   <a:srgbClr val="34495E"/>
                 </a:solidFill>
+                <a:latin typeface="Segoe UI"/>
               </a:defRPr>
             </a:pPr>
             <a:r>
@@ -7743,6 +7749,7 @@
                 <a:solidFill>
                   <a:srgbClr val="C62828"/>
                 </a:solidFill>
+                <a:latin typeface="Segoe UI"/>
               </a:defRPr>
             </a:pPr>
             <a:r>
@@ -7796,6 +7803,7 @@
                 <a:solidFill>
                   <a:srgbClr val="C62828"/>
                 </a:solidFill>
+                <a:latin typeface="Segoe UI"/>
               </a:defRPr>
             </a:pPr>
             <a:r>
@@ -7831,6 +7839,7 @@
                 <a:solidFill>
                   <a:srgbClr val="C62828"/>
                 </a:solidFill>
+                <a:latin typeface="Segoe UI"/>
               </a:defRPr>
             </a:pPr>
             <a:r>
@@ -7866,6 +7875,7 @@
                 <a:solidFill>
                   <a:srgbClr val="C62828"/>
                 </a:solidFill>
+                <a:latin typeface="Segoe UI"/>
               </a:defRPr>
             </a:pPr>
             <a:r>
@@ -7913,7 +7923,11 @@
           <a:bodyPr rtlCol="0" anchor="ctr"/>
           <a:lstStyle/>
           <a:p>
-            <a:pPr algn="ctr"/>
+            <a:pPr algn="ctr">
+              <a:defRPr>
+                <a:latin typeface="Segoe UI"/>
+              </a:defRPr>
+            </a:pPr>
           </a:p>
         </p:txBody>
       </p:sp>
@@ -7940,7 +7954,9 @@
           <a:lstStyle/>
           <a:p>
             <a:pPr algn="ctr">
-              <a:defRPr sz="1400" b="1"/>
+              <a:defRPr sz="1400" b="1">
+                <a:latin typeface="Segoe UI"/>
+              </a:defRPr>
             </a:pPr>
             <a:r>
               <a:t>1</a:t>
@@ -7971,7 +7987,9 @@
           <a:lstStyle/>
           <a:p>
             <a:pPr>
-              <a:defRPr sz="1200"/>
+              <a:defRPr sz="1200">
+                <a:latin typeface="Segoe UI"/>
+              </a:defRPr>
             </a:pPr>
             <a:r>
               <a:t>Q4 2024</a:t>
@@ -8002,7 +8020,9 @@
           <a:lstStyle/>
           <a:p>
             <a:pPr algn="r">
-              <a:defRPr sz="1200" b="1"/>
+              <a:defRPr sz="1200" b="1">
+                <a:latin typeface="Segoe UI"/>
+              </a:defRPr>
             </a:pPr>
             <a:r>
               <a:t>$1.6M</a:t>
@@ -8049,7 +8069,11 @@
           <a:bodyPr rtlCol="0" anchor="ctr"/>
           <a:lstStyle/>
           <a:p>
-            <a:pPr algn="ctr"/>
+            <a:pPr algn="ctr">
+              <a:defRPr>
+                <a:latin typeface="Segoe UI"/>
+              </a:defRPr>
+            </a:pPr>
           </a:p>
         </p:txBody>
       </p:sp>
@@ -8076,7 +8100,9 @@
           <a:lstStyle/>
           <a:p>
             <a:pPr algn="ctr">
-              <a:defRPr sz="1400" b="1"/>
+              <a:defRPr sz="1400" b="1">
+                <a:latin typeface="Segoe UI"/>
+              </a:defRPr>
             </a:pPr>
             <a:r>
               <a:t>2</a:t>
@@ -8107,7 +8133,9 @@
           <a:lstStyle/>
           <a:p>
             <a:pPr>
-              <a:defRPr sz="1200"/>
+              <a:defRPr sz="1200">
+                <a:latin typeface="Segoe UI"/>
+              </a:defRPr>
             </a:pPr>
             <a:r>
               <a:t>Q3 2024</a:t>
@@ -8138,7 +8166,9 @@
           <a:lstStyle/>
           <a:p>
             <a:pPr algn="r">
-              <a:defRPr sz="1200" b="1"/>
+              <a:defRPr sz="1200" b="1">
+                <a:latin typeface="Segoe UI"/>
+              </a:defRPr>
             </a:pPr>
             <a:r>
               <a:t>$1.4M</a:t>
@@ -8185,7 +8215,11 @@
           <a:bodyPr rtlCol="0" anchor="ctr"/>
           <a:lstStyle/>
           <a:p>
-            <a:pPr algn="ctr"/>
+            <a:pPr algn="ctr">
+              <a:defRPr>
+                <a:latin typeface="Segoe UI"/>
+              </a:defRPr>
+            </a:pPr>
           </a:p>
         </p:txBody>
       </p:sp>
@@ -8212,7 +8246,9 @@
           <a:lstStyle/>
           <a:p>
             <a:pPr algn="ctr">
-              <a:defRPr sz="1400" b="1"/>
+              <a:defRPr sz="1400" b="1">
+                <a:latin typeface="Segoe UI"/>
+              </a:defRPr>
             </a:pPr>
             <a:r>
               <a:t>3</a:t>
@@ -8243,7 +8279,9 @@
           <a:lstStyle/>
           <a:p>
             <a:pPr>
-              <a:defRPr sz="1200"/>
+              <a:defRPr sz="1200">
+                <a:latin typeface="Segoe UI"/>
+              </a:defRPr>
             </a:pPr>
             <a:r>
               <a:t>Q2 2024</a:t>
@@ -8274,7 +8312,9 @@
           <a:lstStyle/>
           <a:p>
             <a:pPr algn="r">
-              <a:defRPr sz="1200" b="1"/>
+              <a:defRPr sz="1200" b="1">
+                <a:latin typeface="Segoe UI"/>
+              </a:defRPr>
             </a:pPr>
             <a:r>
               <a:t>$1.4M</a:t>
@@ -8321,7 +8361,11 @@
           <a:bodyPr rtlCol="0" anchor="ctr"/>
           <a:lstStyle/>
           <a:p>
-            <a:pPr algn="ctr"/>
+            <a:pPr algn="ctr">
+              <a:defRPr>
+                <a:latin typeface="Segoe UI"/>
+              </a:defRPr>
+            </a:pPr>
           </a:p>
         </p:txBody>
       </p:sp>
@@ -8348,7 +8392,9 @@
           <a:lstStyle/>
           <a:p>
             <a:pPr algn="ctr">
-              <a:defRPr sz="1400" b="1"/>
+              <a:defRPr sz="1400" b="1">
+                <a:latin typeface="Segoe UI"/>
+              </a:defRPr>
             </a:pPr>
             <a:r>
               <a:t>4</a:t>
@@ -8379,7 +8425,9 @@
           <a:lstStyle/>
           <a:p>
             <a:pPr>
-              <a:defRPr sz="1200"/>
+              <a:defRPr sz="1200">
+                <a:latin typeface="Segoe UI"/>
+              </a:defRPr>
             </a:pPr>
             <a:r>
               <a:t>Q1 2024</a:t>
@@ -8410,7 +8458,9 @@
           <a:lstStyle/>
           <a:p>
             <a:pPr algn="r">
-              <a:defRPr sz="1200" b="1"/>
+              <a:defRPr sz="1200" b="1">
+                <a:latin typeface="Segoe UI"/>
+              </a:defRPr>
             </a:pPr>
             <a:r>
               <a:t>$1.2M</a:t>
@@ -8457,7 +8507,11 @@
           <a:bodyPr rtlCol="0" anchor="ctr"/>
           <a:lstStyle/>
           <a:p>
-            <a:pPr algn="ctr"/>
+            <a:pPr algn="ctr">
+              <a:defRPr>
+                <a:latin typeface="Segoe UI"/>
+              </a:defRPr>
+            </a:pPr>
           </a:p>
         </p:txBody>
       </p:sp>
@@ -8484,7 +8538,9 @@
           <a:lstStyle/>
           <a:p>
             <a:pPr algn="ctr">
-              <a:defRPr sz="1400" b="1"/>
+              <a:defRPr sz="1400" b="1">
+                <a:latin typeface="Segoe UI"/>
+              </a:defRPr>
             </a:pPr>
             <a:r>
               <a:t>5</a:t>
@@ -8515,7 +8571,9 @@
           <a:lstStyle/>
           <a:p>
             <a:pPr>
-              <a:defRPr sz="1200"/>
+              <a:defRPr sz="1200">
+                <a:latin typeface="Segoe UI"/>
+              </a:defRPr>
             </a:pPr>
             <a:r>
               <a:t>nan</a:t>
@@ -8546,7 +8604,9 @@
           <a:lstStyle/>
           <a:p>
             <a:pPr algn="r">
-              <a:defRPr sz="1200" b="1"/>
+              <a:defRPr sz="1200" b="1">
+                <a:latin typeface="Segoe UI"/>
+              </a:defRPr>
             </a:pPr>
             <a:r>
               <a:t>$nan</a:t>
@@ -8593,7 +8653,11 @@
           <a:bodyPr rtlCol="0" anchor="ctr"/>
           <a:lstStyle/>
           <a:p>
-            <a:pPr algn="ctr"/>
+            <a:pPr algn="ctr">
+              <a:defRPr>
+                <a:latin typeface="Segoe UI"/>
+              </a:defRPr>
+            </a:pPr>
           </a:p>
         </p:txBody>
       </p:sp>
@@ -8620,7 +8684,9 @@
           <a:lstStyle/>
           <a:p>
             <a:pPr algn="ctr">
-              <a:defRPr sz="1400" b="1"/>
+              <a:defRPr sz="1400" b="1">
+                <a:latin typeface="Segoe UI"/>
+              </a:defRPr>
             </a:pPr>
             <a:r>
               <a:t>6</a:t>
@@ -8651,7 +8717,9 @@
           <a:lstStyle/>
           <a:p>
             <a:pPr>
-              <a:defRPr sz="1200"/>
+              <a:defRPr sz="1200">
+                <a:latin typeface="Segoe UI"/>
+              </a:defRPr>
             </a:pPr>
             <a:r>
               <a:t>nan</a:t>
@@ -8682,7 +8750,9 @@
           <a:lstStyle/>
           <a:p>
             <a:pPr algn="r">
-              <a:defRPr sz="1200" b="1"/>
+              <a:defRPr sz="1200" b="1">
+                <a:latin typeface="Segoe UI"/>
+              </a:defRPr>
             </a:pPr>
             <a:r>
               <a:t>$nan</a:t>
@@ -8729,7 +8799,11 @@
           <a:bodyPr rtlCol="0" anchor="ctr"/>
           <a:lstStyle/>
           <a:p>
-            <a:pPr algn="ctr"/>
+            <a:pPr algn="ctr">
+              <a:defRPr>
+                <a:latin typeface="Segoe UI"/>
+              </a:defRPr>
+            </a:pPr>
           </a:p>
         </p:txBody>
       </p:sp>
@@ -8756,7 +8830,9 @@
           <a:lstStyle/>
           <a:p>
             <a:pPr algn="ctr">
-              <a:defRPr sz="1400" b="1"/>
+              <a:defRPr sz="1400" b="1">
+                <a:latin typeface="Segoe UI"/>
+              </a:defRPr>
             </a:pPr>
             <a:r>
               <a:t>7</a:t>
@@ -8787,7 +8863,9 @@
           <a:lstStyle/>
           <a:p>
             <a:pPr>
-              <a:defRPr sz="1200"/>
+              <a:defRPr sz="1200">
+                <a:latin typeface="Segoe UI"/>
+              </a:defRPr>
             </a:pPr>
             <a:r>
               <a:t>nan</a:t>
@@ -8818,7 +8896,9 @@
           <a:lstStyle/>
           <a:p>
             <a:pPr algn="r">
-              <a:defRPr sz="1200" b="1"/>
+              <a:defRPr sz="1200" b="1">
+                <a:latin typeface="Segoe UI"/>
+              </a:defRPr>
             </a:pPr>
             <a:r>
               <a:t>$nan</a:t>
@@ -8865,7 +8945,11 @@
           <a:bodyPr rtlCol="0" anchor="ctr"/>
           <a:lstStyle/>
           <a:p>
-            <a:pPr algn="ctr"/>
+            <a:pPr algn="ctr">
+              <a:defRPr>
+                <a:latin typeface="Segoe UI"/>
+              </a:defRPr>
+            </a:pPr>
           </a:p>
         </p:txBody>
       </p:sp>
@@ -8892,7 +8976,9 @@
           <a:lstStyle/>
           <a:p>
             <a:pPr algn="ctr">
-              <a:defRPr sz="1400" b="1"/>
+              <a:defRPr sz="1400" b="1">
+                <a:latin typeface="Segoe UI"/>
+              </a:defRPr>
             </a:pPr>
             <a:r>
               <a:t>8</a:t>
@@ -8923,7 +9009,9 @@
           <a:lstStyle/>
           <a:p>
             <a:pPr>
-              <a:defRPr sz="1200"/>
+              <a:defRPr sz="1200">
+                <a:latin typeface="Segoe UI"/>
+              </a:defRPr>
             </a:pPr>
             <a:r>
               <a:t>nan</a:t>
@@ -8954,7 +9042,9 @@
           <a:lstStyle/>
           <a:p>
             <a:pPr algn="r">
-              <a:defRPr sz="1200" b="1"/>
+              <a:defRPr sz="1200" b="1">
+                <a:latin typeface="Segoe UI"/>
+              </a:defRPr>
             </a:pPr>
             <a:r>
               <a:t>$nan</a:t>
@@ -9007,6 +9097,7 @@
                 <a:solidFill>
                   <a:srgbClr val="C62828"/>
                 </a:solidFill>
+                <a:latin typeface="Segoe UI"/>
               </a:defRPr>
             </a:pPr>
             <a:r>
@@ -9036,7 +9127,13 @@
             <a:spAutoFit/>
           </a:bodyPr>
           <a:lstStyle/>
-          <a:p/>
+          <a:p>
+            <a:pPr>
+              <a:defRPr>
+                <a:latin typeface="Segoe UI"/>
+              </a:defRPr>
+            </a:pPr>
+          </a:p>
           <a:p>
             <a:pPr>
               <a:spcAft>
@@ -9046,6 +9143,7 @@
                 <a:solidFill>
                   <a:srgbClr val="34495E"/>
                 </a:solidFill>
+                <a:latin typeface="Segoe UI"/>
               </a:defRPr>
             </a:pPr>
             <a:r>
@@ -9061,6 +9159,7 @@
                 <a:solidFill>
                   <a:srgbClr val="34495E"/>
                 </a:solidFill>
+                <a:latin typeface="Segoe UI"/>
               </a:defRPr>
             </a:pPr>
             <a:r>
@@ -9076,6 +9175,7 @@
                 <a:solidFill>
                   <a:srgbClr val="34495E"/>
                 </a:solidFill>
+                <a:latin typeface="Segoe UI"/>
               </a:defRPr>
             </a:pPr>
             <a:r>
@@ -9091,6 +9191,7 @@
                 <a:solidFill>
                   <a:srgbClr val="34495E"/>
                 </a:solidFill>
+                <a:latin typeface="Segoe UI"/>
               </a:defRPr>
             </a:pPr>
             <a:r>

</xml_diff>